<commit_message>
marketing: deck v2.1 (Morgan mulberry per ux 629a682) + attribution amendment for f242a0d sweep
Co-Authored-By: Claude Fable 5 <noreply@anthropic.com>
Claude-Session: https://claude.ai/code/session_016SVmxwRcYE9NdqSHLVdcDw
</commit_message>
<xml_diff>
--- a/docs/sis/marketing/AuthorsLab-Blair-Klein-Deck-v2.pptx
+++ b/docs/sis/marketing/AuthorsLab-Blair-Klein-Deck-v2.pptx
@@ -2393,7 +2393,7 @@
             <a:avLst/>
           </a:prstGeom>
           <a:solidFill>
-            <a:srgbClr val="C68A3C"/>
+            <a:srgbClr val="8E4A72"/>
           </a:solidFill>
           <a:ln/>
         </p:spPr>
@@ -5096,7 +5096,7 @@
             <a:avLst/>
           </a:prstGeom>
           <a:solidFill>
-            <a:srgbClr val="C68A3C"/>
+            <a:srgbClr val="8E4A72"/>
           </a:solidFill>
           <a:ln/>
         </p:spPr>
@@ -5814,11 +5814,11 @@
             </a:avLst>
           </a:prstGeom>
           <a:solidFill>
-            <a:srgbClr val="FDF6EE"/>
+            <a:srgbClr val="F3EAF0"/>
           </a:solidFill>
           <a:ln w="12700">
             <a:solidFill>
-              <a:srgbClr val="EFDFC8"/>
+              <a:srgbClr val="E3D3DE"/>
             </a:solidFill>
             <a:prstDash val="solid"/>
           </a:ln>
@@ -5851,7 +5851,7 @@
             <a:r>
               <a:rPr lang="en-US" sz="1200" spc="300" kern="0" dirty="0">
                 <a:solidFill>
-                  <a:srgbClr val="8F6F2C"/>
+                  <a:srgbClr val="6E3757"/>
                 </a:solidFill>
                 <a:latin typeface="Calibri" pitchFamily="34" charset="0"/>
                 <a:ea typeface="Calibri" pitchFamily="34" charset="-122"/>
@@ -5890,7 +5890,7 @@
             <a:r>
               <a:rPr lang="en-US" sz="1350" i="1" dirty="0">
                 <a:solidFill>
-                  <a:srgbClr val="8F6F2C"/>
+                  <a:srgbClr val="6E3757"/>
                 </a:solidFill>
                 <a:latin typeface="Palatino Linotype" pitchFamily="34" charset="0"/>
                 <a:ea typeface="Palatino Linotype" pitchFamily="34" charset="-122"/>

</xml_diff>